<commit_message>
Sjöskolan vecka 43 fredag och vecka 44: ledtrådar utan labbets svar, Isolationslabbet på två dagar
Ledtråd 3 i övning 3.7 och 3.8 räknar med 48 V i stället för labbets 24 V.
Isolationslabbet delas på måndag (jordfel, mätning 1–5) och tisdag (isolations-
provning, mätning 6–8). Upplägg, avslutsfrågor och veckans rad stämmer med
bilderna och inlämningen. Ledtråd 1 skriver hela meningar som meningar.
Neutralpunktsfiguren har texten inne i slingan.

Co-Authored-By: Claude Opus 5.5 <noreply@anthropic.com>
Claude-Session: https://claude.ai/code/session_01E6DNWu8trXB9zSZC1cgTtp
</commit_message>
<xml_diff>
--- a/sjoskolan/vecka-43/aktuell/v43_03_Elscheman_och_dokumentation_elev.pptx
+++ b/sjoskolan/vecka-43/aktuell/v43_03_Elscheman_och_dokumentation_elev.pptx
@@ -4645,7 +4645,7 @@
                 </a:solidFill>
                 <a:latin typeface="Calibri"/>
               </a:rPr>
-              <a:t>I inlämningen ingår funktion, komponenter och förväntade mätvärden vid definierade mätpunkter.</a:t>
+              <a:t>Inlämning 3 bygger på hållkretsen: nödstoppet, lampan, kretsens fem lägen och en felsökningsrad.</a:t>
             </a:r>
           </a:p>
         </p:txBody>
@@ -5979,7 +5979,7 @@
                 </a:solidFill>
                 <a:latin typeface="Calibri"/>
               </a:rPr>
-              <a:t>Inlämning 3 bygger på hållkretsen: redovisa funktion, komponenter och förväntade mätvärden vid definierade mätpunkter. Inlämningen senast i dag, fredag 23 oktober.</a:t>
+              <a:t>Inlämning 3 bygger på hållkretsen: nödstoppet S2, lampan H1, kretsens fem lägen och en felsökningsrad. Inlämningen senast i dag, fredag 23 oktober.</a:t>
             </a:r>
           </a:p>
         </p:txBody>
@@ -6578,7 +6578,7 @@
                 </a:solidFill>
                 <a:latin typeface="Calibri"/>
               </a:rPr>
-              <a:t>Inlämningen och felsökningsrapporten senast i dag, fredag 23 oktober. Allt finns på veckosidan.</a:t>
+              <a:t>Inlämningen, uppgift 1–4, senast i dag, fredag 23 oktober. Allt finns på veckosidan.</a:t>
             </a:r>
           </a:p>
         </p:txBody>

</xml_diff>

<commit_message>
Balance Week 43 Friday instruction and independent practice
Retain both complete presentations and all assessment content. Focus classroom exercises on circuit interpretation, fault localisation, documentation and verification; mark repeated Friday practice optional without counting it as unfinished homework.

Regenerate PowerPoint, PDF, web slides and student guidance. Friday teacher instructions updated in their existing Google Doc.

Validation: 21 Python tests; 19 Node checks passed (one protected-answer check unavailable); eight desktop/phone browser journeys; 305 local links; assessment and protected files unchanged. WebKit could not launch because host libraries are missing.
</commit_message>
<xml_diff>
--- a/sjoskolan/vecka-43/aktuell/v43_03_Elscheman_och_dokumentation_elev.pptx
+++ b/sjoskolan/vecka-43/aktuell/v43_03_Elscheman_och_dokumentation_elev.pptx
@@ -5631,14 +5631,140 @@
       </p:sp>
       <p:sp>
         <p:nvSpPr>
-          <p:cNvPr id="11" name="TextBox 10"/>
+          <p:cNvPr id="11" name="Rectangle 10"/>
+          <p:cNvSpPr/>
+          <p:nvPr/>
+        </p:nvSpPr>
+        <p:spPr>
+          <a:xfrm>
+            <a:off x="548640" y="3410712"/>
+            <a:ext cx="8046720" cy="566928"/>
+          </a:xfrm>
+          <a:prstGeom prst="rect">
+            <a:avLst/>
+          </a:prstGeom>
+          <a:solidFill>
+            <a:srgbClr val="F2F5F9"/>
+          </a:solidFill>
+          <a:ln>
+            <a:noFill/>
+          </a:ln>
+          <a:effectLst/>
+        </p:spPr>
+        <p:style>
+          <a:lnRef idx="1">
+            <a:schemeClr val="accent1"/>
+          </a:lnRef>
+          <a:fillRef idx="3">
+            <a:schemeClr val="accent1"/>
+          </a:fillRef>
+          <a:effectRef idx="2">
+            <a:schemeClr val="accent1"/>
+          </a:effectRef>
+          <a:fontRef idx="minor">
+            <a:schemeClr val="lt1"/>
+          </a:fontRef>
+        </p:style>
+        <p:txBody>
+          <a:bodyPr rtlCol="0" anchor="ctr"/>
+          <a:lstStyle/>
+          <a:p/>
+        </p:txBody>
+      </p:sp>
+      <p:sp>
+        <p:nvSpPr>
+          <p:cNvPr id="12" name="TextBox 11"/>
           <p:cNvSpPr txBox="1"/>
           <p:nvPr/>
         </p:nvSpPr>
         <p:spPr>
           <a:xfrm>
-            <a:off x="548640" y="3547872"/>
-            <a:ext cx="8046720" cy="2350008"/>
+            <a:off x="685800" y="3410712"/>
+            <a:ext cx="1737360" cy="566928"/>
+          </a:xfrm>
+          <a:prstGeom prst="rect">
+            <a:avLst/>
+          </a:prstGeom>
+          <a:noFill/>
+        </p:spPr>
+        <p:txBody>
+          <a:bodyPr wrap="square" anchor="ctr" lIns="27432" rIns="27432" tIns="18288" bIns="18288">
+            <a:spAutoFit/>
+          </a:bodyPr>
+          <a:lstStyle/>
+          <a:p>
+            <a:pPr algn="l">
+              <a:lnSpc>
+                <a:spcPct val="108000"/>
+              </a:lnSpc>
+              <a:spcAft>
+                <a:spcPts val="0"/>
+              </a:spcAft>
+            </a:pPr>
+            <a:r>
+              <a:rPr sz="2000" b="1" i="0">
+                <a:solidFill>
+                  <a:srgbClr val="111111"/>
+                </a:solidFill>
+                <a:latin typeface="Calibri"/>
+              </a:rPr>
+              <a:t>Övning 3.9</a:t>
+            </a:r>
+          </a:p>
+        </p:txBody>
+      </p:sp>
+      <p:sp>
+        <p:nvSpPr>
+          <p:cNvPr id="13" name="TextBox 12"/>
+          <p:cNvSpPr txBox="1"/>
+          <p:nvPr/>
+        </p:nvSpPr>
+        <p:spPr>
+          <a:xfrm>
+            <a:off x="2468880" y="3410712"/>
+            <a:ext cx="6035040" cy="566928"/>
+          </a:xfrm>
+          <a:prstGeom prst="rect">
+            <a:avLst/>
+          </a:prstGeom>
+          <a:noFill/>
+        </p:spPr>
+        <p:txBody>
+          <a:bodyPr wrap="square" anchor="ctr" lIns="27432" rIns="27432" tIns="18288" bIns="18288">
+            <a:spAutoFit/>
+          </a:bodyPr>
+          <a:lstStyle/>
+          <a:p>
+            <a:pPr algn="l">
+              <a:lnSpc>
+                <a:spcPct val="108000"/>
+              </a:lnSpc>
+              <a:spcAft>
+                <a:spcPts val="0"/>
+              </a:spcAft>
+            </a:pPr>
+            <a:r>
+              <a:rPr sz="2000" b="0" i="0">
+                <a:solidFill>
+                  <a:srgbClr val="111111"/>
+                </a:solidFill>
+                <a:latin typeface="Calibri"/>
+              </a:rPr>
+              <a:t>Brist i en ritning</a:t>
+            </a:r>
+          </a:p>
+        </p:txBody>
+      </p:sp>
+      <p:sp>
+        <p:nvSpPr>
+          <p:cNvPr id="14" name="TextBox 13"/>
+          <p:cNvSpPr txBox="1"/>
+          <p:nvPr/>
+        </p:nvSpPr>
+        <p:spPr>
+          <a:xfrm>
+            <a:off x="548640" y="4224528"/>
+            <a:ext cx="8046720" cy="1673351"/>
           </a:xfrm>
           <a:prstGeom prst="rect">
             <a:avLst/>
@@ -5666,7 +5792,7 @@
                 </a:solidFill>
                 <a:latin typeface="Calibri"/>
               </a:rPr>
-              <a:t>Fem minuter per övning. Skriv ditt svar i chatten. Övning 3.8–3.10 gör du själv efter lektionen.</a:t>
+              <a:t>Fem minuter per övning: försök själv, använd ledtråd vid behov och jämför sedan med facit. Ange mätpunkter och driftläge i 3.6–3.7. Spara din motivering.</a:t>
             </a:r>
           </a:p>
           <a:p>
@@ -5692,7 +5818,7 @@
       </p:sp>
       <p:pic>
         <p:nvPicPr>
-          <p:cNvPr id="12" name="Picture 11" descr="sidfot.jpg"/>
+          <p:cNvPr id="15" name="Picture 14" descr="sidfot.jpg"/>
           <p:cNvPicPr>
             <a:picLocks noChangeAspect="1"/>
           </p:cNvPicPr>
@@ -5716,7 +5842,7 @@
       </p:pic>
       <p:sp>
         <p:nvSpPr>
-          <p:cNvPr id="13" name="TextBox 12"/>
+          <p:cNvPr id="16" name="TextBox 15"/>
           <p:cNvSpPr txBox="1"/>
           <p:nvPr/>
         </p:nvSpPr>
@@ -5758,7 +5884,7 @@
       </p:sp>
       <p:sp>
         <p:nvSpPr>
-          <p:cNvPr id="14" name="TextBox 13"/>
+          <p:cNvPr id="17" name="TextBox 16"/>
           <p:cNvSpPr txBox="1"/>
           <p:nvPr/>
         </p:nvSpPr>
@@ -6521,7 +6647,7 @@
                 </a:solidFill>
                 <a:latin typeface="Calibri"/>
               </a:rPr>
-              <a:t>1. Gör övning 3.8–3.10 på delsidan. Ledtrådar och facit finns där.</a:t>
+              <a:t>1. Frivillig extra träning: övning 3.8 och 3.10. Prioritera inlämningen. Ledtrådar och facit finns på delsidan.</a:t>
             </a:r>
           </a:p>
           <a:p>
@@ -8297,7 +8423,7 @@
                 </a:solidFill>
                 <a:latin typeface="Calibri"/>
               </a:rPr>
-              <a:t>Pass 1: Genomgång av del 3 med era frågor (avsnitt 1–7)</a:t>
+              <a:t>Pass 1: Era frågor om scheman och mätpunkter (avsnitt 1–7)</a:t>
             </a:r>
           </a:p>
         </p:txBody>
@@ -8339,7 +8465,7 @@
                 </a:solidFill>
                 <a:latin typeface="Calibri"/>
               </a:rPr>
-              <a:t>09.30</a:t>
+              <a:t>09.20</a:t>
             </a:r>
           </a:p>
         </p:txBody>
@@ -8381,7 +8507,7 @@
                 </a:solidFill>
                 <a:latin typeface="Calibri"/>
               </a:rPr>
-              <a:t>Övning 3.6 och 3.7 tillsammans</a:t>
+              <a:t>Eget försök: övning 3.6, 3.7 och 3.9</a:t>
             </a:r>
           </a:p>
         </p:txBody>
@@ -8423,7 +8549,7 @@
                 </a:solidFill>
                 <a:latin typeface="Calibri"/>
               </a:rPr>
-              <a:t>09.40</a:t>
+              <a:t>09.35</a:t>
             </a:r>
           </a:p>
         </p:txBody>
@@ -8465,20 +8591,104 @@
                 </a:solidFill>
                 <a:latin typeface="Calibri"/>
               </a:rPr>
-              <a:t>Avslutsfråga, sammanfattning och det här gör du nu</a:t>
-            </a:r>
-          </a:p>
-        </p:txBody>
-      </p:sp>
-      <p:sp>
-        <p:nvSpPr>
-          <p:cNvPr id="12" name="Rectangle 11"/>
+              <a:t>Jämför resonemang och avslutsfråga</a:t>
+            </a:r>
+          </a:p>
+        </p:txBody>
+      </p:sp>
+      <p:sp>
+        <p:nvSpPr>
+          <p:cNvPr id="12" name="TextBox 11"/>
+          <p:cNvSpPr txBox="1"/>
+          <p:nvPr/>
+        </p:nvSpPr>
+        <p:spPr>
+          <a:xfrm>
+            <a:off x="640080" y="3685032"/>
+            <a:ext cx="1005840" cy="512064"/>
+          </a:xfrm>
+          <a:prstGeom prst="rect">
+            <a:avLst/>
+          </a:prstGeom>
+          <a:noFill/>
+        </p:spPr>
+        <p:txBody>
+          <a:bodyPr wrap="square" anchor="ctr" lIns="27432" rIns="27432" tIns="18288" bIns="18288">
+            <a:spAutoFit/>
+          </a:bodyPr>
+          <a:lstStyle/>
+          <a:p>
+            <a:pPr algn="l">
+              <a:lnSpc>
+                <a:spcPct val="108000"/>
+              </a:lnSpc>
+              <a:spcAft>
+                <a:spcPts val="0"/>
+              </a:spcAft>
+            </a:pPr>
+            <a:r>
+              <a:rPr sz="1800" b="1" i="0">
+                <a:solidFill>
+                  <a:srgbClr val="064F91"/>
+                </a:solidFill>
+                <a:latin typeface="Calibri"/>
+              </a:rPr>
+              <a:t>09.45</a:t>
+            </a:r>
+          </a:p>
+        </p:txBody>
+      </p:sp>
+      <p:sp>
+        <p:nvSpPr>
+          <p:cNvPr id="13" name="TextBox 12"/>
+          <p:cNvSpPr txBox="1"/>
+          <p:nvPr/>
+        </p:nvSpPr>
+        <p:spPr>
+          <a:xfrm>
+            <a:off x="1783080" y="3685032"/>
+            <a:ext cx="6720840" cy="512064"/>
+          </a:xfrm>
+          <a:prstGeom prst="rect">
+            <a:avLst/>
+          </a:prstGeom>
+          <a:noFill/>
+        </p:spPr>
+        <p:txBody>
+          <a:bodyPr wrap="square" anchor="ctr" lIns="27432" rIns="27432" tIns="18288" bIns="18288">
+            <a:spAutoFit/>
+          </a:bodyPr>
+          <a:lstStyle/>
+          <a:p>
+            <a:pPr algn="l">
+              <a:lnSpc>
+                <a:spcPct val="108000"/>
+              </a:lnSpc>
+              <a:spcAft>
+                <a:spcPts val="0"/>
+              </a:spcAft>
+            </a:pPr>
+            <a:r>
+              <a:rPr sz="1800" b="0" i="0">
+                <a:solidFill>
+                  <a:srgbClr val="111111"/>
+                </a:solidFill>
+                <a:latin typeface="Calibri"/>
+              </a:rPr>
+              <a:t>Frågor och nästa steg</a:t>
+            </a:r>
+          </a:p>
+        </p:txBody>
+      </p:sp>
+      <p:sp>
+        <p:nvSpPr>
+          <p:cNvPr id="14" name="Rectangle 13"/>
           <p:cNvSpPr/>
           <p:nvPr/>
         </p:nvSpPr>
         <p:spPr>
           <a:xfrm>
-            <a:off x="548640" y="3685032"/>
+            <a:off x="548640" y="4251960"/>
             <a:ext cx="8046720" cy="512064"/>
           </a:xfrm>
           <a:prstGeom prst="rect">
@@ -8514,13 +8724,13 @@
       </p:sp>
       <p:sp>
         <p:nvSpPr>
-          <p:cNvPr id="13" name="TextBox 12"/>
+          <p:cNvPr id="15" name="TextBox 14"/>
           <p:cNvSpPr txBox="1"/>
           <p:nvPr/>
         </p:nvSpPr>
         <p:spPr>
           <a:xfrm>
-            <a:off x="640080" y="3685032"/>
+            <a:off x="640080" y="4251960"/>
             <a:ext cx="1005840" cy="512064"/>
           </a:xfrm>
           <a:prstGeom prst="rect">
@@ -8556,13 +8766,13 @@
       </p:sp>
       <p:sp>
         <p:nvSpPr>
-          <p:cNvPr id="14" name="TextBox 13"/>
+          <p:cNvPr id="16" name="TextBox 15"/>
           <p:cNvSpPr txBox="1"/>
           <p:nvPr/>
         </p:nvSpPr>
         <p:spPr>
           <a:xfrm>
-            <a:off x="1783080" y="3685032"/>
+            <a:off x="1783080" y="4251960"/>
             <a:ext cx="6720840" cy="512064"/>
           </a:xfrm>
           <a:prstGeom prst="rect">
@@ -8598,7 +8808,7 @@
       </p:sp>
       <p:pic>
         <p:nvPicPr>
-          <p:cNvPr id="15" name="Picture 14" descr="sidfot.jpg"/>
+          <p:cNvPr id="17" name="Picture 16" descr="sidfot.jpg"/>
           <p:cNvPicPr>
             <a:picLocks noChangeAspect="1"/>
           </p:cNvPicPr>
@@ -8622,7 +8832,7 @@
       </p:pic>
       <p:sp>
         <p:nvSpPr>
-          <p:cNvPr id="16" name="TextBox 15"/>
+          <p:cNvPr id="18" name="TextBox 17"/>
           <p:cNvSpPr txBox="1"/>
           <p:nvPr/>
         </p:nvSpPr>
@@ -8664,7 +8874,7 @@
       </p:sp>
       <p:sp>
         <p:nvSpPr>
-          <p:cNvPr id="17" name="TextBox 16"/>
+          <p:cNvPr id="19" name="TextBox 18"/>
           <p:cNvSpPr txBox="1"/>
           <p:nvPr/>
         </p:nvSpPr>

</xml_diff>